<commit_message>
fix: renew loans condition
</commit_message>
<xml_diff>
--- a/FinalPresentation_LibraryManagement.pptx
+++ b/FinalPresentation_LibraryManagement.pptx
@@ -1864,10 +1864,10 @@
       </p:grpSpPr>
       <p:sp>
         <p:nvSpPr>
-          <p:cNvPr id="7" name="9Slide.vn - 2019">
+          <p:cNvPr id="2" name="9Slide.vn - 2019">
             <a:extLst>
               <a:ext uri="{FF2B5EF4-FFF2-40B4-BE49-F238E27FC236}">
-                <a16:creationId xmlns:a16="http://schemas.microsoft.com/office/drawing/2014/main" id="{4BA02655-BFB8-B398-D9B0-083628BD474C}"/>
+                <a16:creationId xmlns:a16="http://schemas.microsoft.com/office/drawing/2014/main" id="{684624F3-F978-EE9C-B8D5-E0572E16C032}"/>
               </a:ext>
             </a:extLst>
           </p:cNvPr>
@@ -17788,7 +17788,29 @@
                 <a:ea typeface="Calibri" pitchFamily="34" charset="-122"/>
                 <a:cs typeface="Calibri" pitchFamily="34" charset="-120"/>
               </a:rPr>
-              <a:t>Role-based access: Student, Lecturer, Researcher, Admin</a:t>
+              <a:t>Role-based access: Student, Lecturer, Researcher</a:t>
+            </a:r>
+            <a:r>
+              <a:rPr lang="en-US" sz="1300">
+                <a:solidFill>
+                  <a:srgbClr val="2D3748"/>
+                </a:solidFill>
+                <a:latin typeface="Calibri" pitchFamily="34" charset="0"/>
+                <a:ea typeface="Calibri" pitchFamily="34" charset="-122"/>
+                <a:cs typeface="Calibri" pitchFamily="34" charset="-120"/>
+              </a:rPr>
+              <a:t>, </a:t>
+            </a:r>
+            <a:r>
+              <a:rPr lang="vi-VN" sz="1300">
+                <a:solidFill>
+                  <a:srgbClr val="2D3748"/>
+                </a:solidFill>
+                <a:latin typeface="Calibri" pitchFamily="34" charset="0"/>
+                <a:ea typeface="Calibri" pitchFamily="34" charset="-122"/>
+                <a:cs typeface="Calibri" pitchFamily="34" charset="-120"/>
+              </a:rPr>
+              <a:t>Admin, Librarian</a:t>
             </a:r>
             <a:endParaRPr lang="en-US" sz="1300" dirty="0"/>
           </a:p>

</xml_diff>